<commit_message>
Use white logo variant on dark cover + back slides of 회사소개서
The PPTX cover and back-cover slides were using the default dark logo on dark navy background, making the wordmark nearly invisible. Added public/images/logo-white.png (alpha-preserving white re-color of the original) and wired the two dark slides to use it.

- public/images/logo-white.png — generated by PIL (all non-transparent pixels mapped to white, alpha kept)
- scripts/build_pptx.js — references LOGO_WHITE on cover (slide 1) and back-cover (slide 16)
- Rebuilt PPTX + PDF placed in public/files/

Co-Authored-By: Claude Opus 4.7 <noreply@anthropic.com>
</commit_message>
<xml_diff>
--- a/public/files/websLAB-brochure.pptx
+++ b/public/files/websLAB-brochure.pptx
@@ -2303,7 +2303,7 @@
       </p:sp>
       <p:pic>
         <p:nvPicPr>
-          <p:cNvPr id="5" name="Image 0" descr="/Users/dooya8787/Desktop/webslab.co.kr/.claude/worktrees/gallant-nightingale-ceeee6/public/images/logo.png">    </p:cNvPr>
+          <p:cNvPr id="5" name="Image 0" descr="/Users/dooya8787/Desktop/webslab.co.kr/.claude/worktrees/gallant-nightingale-ceeee6/public/images/logo-white.png">    </p:cNvPr>
           <p:cNvPicPr>
             <a:picLocks noChangeAspect="1"/>
           </p:cNvPicPr>
@@ -11336,7 +11336,7 @@
       </p:sp>
       <p:pic>
         <p:nvPicPr>
-          <p:cNvPr id="4" name="Image 0" descr="/Users/dooya8787/Desktop/webslab.co.kr/.claude/worktrees/gallant-nightingale-ceeee6/public/images/logo.png">    </p:cNvPr>
+          <p:cNvPr id="4" name="Image 0" descr="/Users/dooya8787/Desktop/webslab.co.kr/.claude/worktrees/gallant-nightingale-ceeee6/public/images/logo-white.png">    </p:cNvPr>
           <p:cNvPicPr>
             <a:picLocks noChangeAspect="1"/>
           </p:cNvPicPr>

</xml_diff>

<commit_message>
Replace slide 8 OECD with 코스모스악기 · Roland Korea brochure portfolio
Previous slide 8 (OECD 조세정책본부 홈페이지 리뉴얼) wasn't an actual websLAB project — it was a placeholder carried over from the data. Replaced with the real Roland Korea brand site built for 코스모스악기 (official Roland importer).

- Project: 브랜드 사이트 신규 제작, BRAND / MUSIC tag
- Period: 2024.06 – 2024.12
- Services: UI/UX 신규, 브랜드 사이트, CMS 구축, 미디어 큐레이션
- Summary: Roland 글로벌 브랜드의 한국 공식 사이트. 제품 카탈로그·영상·뉴스를 마케팅 팀이 직접 운영하도록 CMS 기반으로 신규 구축.
- Results: 제품 카테고리 9개 · 콘텐츠 모듈 3개 · 자체 CMS 운영

Live site: rolandkorea.com

Co-Authored-By: Claude Opus 4.7 <noreply@anthropic.com>
</commit_message>
<xml_diff>
--- a/public/files/websLAB-brochure.pptx
+++ b/public/files/websLAB-brochure.pptx
@@ -20341,7 +20341,7 @@
                 <a:ea typeface="Pretendard" pitchFamily="34" charset="-122"/>
                 <a:cs typeface="Pretendard" pitchFamily="34" charset="-120"/>
               </a:rPr>
-              <a:t>PORTFOLIO  /  01 of 12  ·  PUBLIC</a:t>
+              <a:t>PORTFOLIO  /  01 of 12  ·  BRAND / MUSIC</a:t>
             </a:r>
             <a:endParaRPr lang="en-US" sz="1000" dirty="0"/>
           </a:p>
@@ -20380,7 +20380,7 @@
                 <a:ea typeface="Pretendard" pitchFamily="34" charset="-122"/>
                 <a:cs typeface="Pretendard" pitchFamily="34" charset="-120"/>
               </a:rPr>
-              <a:t>OECD 조세정책본부</a:t>
+              <a:t>코스모스악기 · Roland Korea</a:t>
             </a:r>
             <a:endParaRPr lang="en-US" sz="4000" dirty="0"/>
           </a:p>
@@ -20419,7 +20419,7 @@
                 <a:ea typeface="Pretendard" pitchFamily="34" charset="-122"/>
                 <a:cs typeface="Pretendard" pitchFamily="34" charset="-120"/>
               </a:rPr>
-              <a:t>홈페이지 리뉴얼</a:t>
+              <a:t>브랜드 사이트 신규 제작</a:t>
             </a:r>
             <a:endParaRPr lang="en-US" sz="1800" dirty="0"/>
           </a:p>
@@ -20588,7 +20588,7 @@
                 <a:ea typeface="Pretendard" pitchFamily="34" charset="-122"/>
                 <a:cs typeface="Pretendard" pitchFamily="34" charset="-120"/>
               </a:rPr>
-              <a:t>10년치 정책 보고서 DB를 무중단 마이그레이션. 한·영 다국어 사이트 구조 재설계.</a:t>
+              <a:t>Roland 글로벌 브랜드의 한국 공식 사이트. 제품 카탈로그·영상·뉴스를 마케팅 팀이 직접 운영하도록 CMS 기반으로 신규 구축.</a:t>
             </a:r>
             <a:endParaRPr lang="en-US" sz="1500" dirty="0"/>
           </a:p>
@@ -20654,7 +20654,7 @@
                 <a:ea typeface="Pretendard" pitchFamily="34" charset="-122"/>
                 <a:cs typeface="Pretendard" pitchFamily="34" charset="-120"/>
               </a:rPr>
-              <a:t>UI/UX 리뉴얼</a:t>
+              <a:t>UI/UX 신규</a:t>
             </a:r>
             <a:endParaRPr lang="en-US" sz="1000" dirty="0"/>
           </a:p>
@@ -20720,7 +20720,7 @@
                 <a:ea typeface="Pretendard" pitchFamily="34" charset="-122"/>
                 <a:cs typeface="Pretendard" pitchFamily="34" charset="-120"/>
               </a:rPr>
-              <a:t>DB 마이그레이션</a:t>
+              <a:t>브랜드 사이트</a:t>
             </a:r>
             <a:endParaRPr lang="en-US" sz="1000" dirty="0"/>
           </a:p>
@@ -20786,7 +20786,7 @@
                 <a:ea typeface="Pretendard" pitchFamily="34" charset="-122"/>
                 <a:cs typeface="Pretendard" pitchFamily="34" charset="-120"/>
               </a:rPr>
-              <a:t>다국어</a:t>
+              <a:t>CMS 구축</a:t>
             </a:r>
             <a:endParaRPr lang="en-US" sz="1000" dirty="0"/>
           </a:p>
@@ -20794,7 +20794,73 @@
       </p:sp>
       <p:sp>
         <p:nvSpPr>
-          <p:cNvPr id="22" name="Text 19"/>
+          <p:cNvPr id="22" name="Shape 19"/>
+          <p:cNvSpPr/>
+          <p:nvPr/>
+        </p:nvSpPr>
+        <p:spPr>
+          <a:xfrm>
+            <a:off x="914400" y="5440680"/>
+            <a:ext cx="1554480" cy="292608"/>
+          </a:xfrm>
+          <a:prstGeom prst="roundRect">
+            <a:avLst>
+              <a:gd name="adj" fmla="val 12500"/>
+            </a:avLst>
+          </a:prstGeom>
+          <a:solidFill>
+            <a:srgbClr val="1A2D52"/>
+          </a:solidFill>
+          <a:ln w="5080">
+            <a:solidFill>
+              <a:srgbClr val="00D4FF"/>
+            </a:solidFill>
+            <a:prstDash val="solid"/>
+          </a:ln>
+        </p:spPr>
+      </p:sp>
+      <p:sp>
+        <p:nvSpPr>
+          <p:cNvPr id="23" name="Text 20"/>
+          <p:cNvSpPr/>
+          <p:nvPr/>
+        </p:nvSpPr>
+        <p:spPr>
+          <a:xfrm>
+            <a:off x="914400" y="5440680"/>
+            <a:ext cx="1554480" cy="292608"/>
+          </a:xfrm>
+          <a:prstGeom prst="rect">
+            <a:avLst/>
+          </a:prstGeom>
+          <a:noFill/>
+          <a:ln/>
+        </p:spPr>
+        <p:txBody>
+          <a:bodyPr wrap="square" rtlCol="0" anchor="ctr"/>
+          <a:lstStyle/>
+          <a:p>
+            <a:pPr algn="ctr" indent="0" marL="0">
+              <a:buNone/>
+            </a:pPr>
+            <a:r>
+              <a:rPr lang="en-US" sz="1000" dirty="0">
+                <a:solidFill>
+                  <a:srgbClr val="00D4FF"/>
+                </a:solidFill>
+                <a:latin typeface="Pretendard" pitchFamily="34" charset="0"/>
+                <a:ea typeface="Pretendard" pitchFamily="34" charset="-122"/>
+                <a:cs typeface="Pretendard" pitchFamily="34" charset="-120"/>
+              </a:rPr>
+              <a:t>미디어 큐레이션</a:t>
+            </a:r>
+            <a:endParaRPr lang="en-US" sz="1000" dirty="0"/>
+          </a:p>
+        </p:txBody>
+      </p:sp>
+      <p:sp>
+        <p:nvSpPr>
+          <p:cNvPr id="24" name="Text 21"/>
           <p:cNvSpPr/>
           <p:nvPr/>
         </p:nvSpPr>
@@ -20833,7 +20899,7 @@
       </p:sp>
       <p:sp>
         <p:nvSpPr>
-          <p:cNvPr id="23" name="Text 20"/>
+          <p:cNvPr id="25" name="Text 22"/>
           <p:cNvSpPr/>
           <p:nvPr/>
         </p:nvSpPr>
@@ -20864,7 +20930,7 @@
                 <a:ea typeface="Pretendard" pitchFamily="34" charset="-122"/>
                 <a:cs typeface="Pretendard" pitchFamily="34" charset="-120"/>
               </a:rPr>
-              <a:t>2023.06 – 2023.10</a:t>
+              <a:t>2024.06 – 2024.12</a:t>
             </a:r>
             <a:endParaRPr lang="en-US" sz="1700" dirty="0"/>
           </a:p>
@@ -20872,7 +20938,7 @@
       </p:sp>
       <p:sp>
         <p:nvSpPr>
-          <p:cNvPr id="24" name="Text 21"/>
+          <p:cNvPr id="26" name="Text 23"/>
           <p:cNvSpPr/>
           <p:nvPr/>
         </p:nvSpPr>
@@ -20911,7 +20977,7 @@
       </p:sp>
       <p:sp>
         <p:nvSpPr>
-          <p:cNvPr id="25" name="Text 22"/>
+          <p:cNvPr id="27" name="Text 24"/>
           <p:cNvSpPr/>
           <p:nvPr/>
         </p:nvSpPr>
@@ -20942,7 +21008,7 @@
                 <a:ea typeface="Pretendard" pitchFamily="34" charset="-122"/>
                 <a:cs typeface="Pretendard" pitchFamily="34" charset="-120"/>
               </a:rPr>
-              <a:t>공공</a:t>
+              <a:t>브랜드 · 음악</a:t>
             </a:r>
             <a:endParaRPr lang="en-US" sz="1700" dirty="0"/>
           </a:p>
@@ -20950,7 +21016,7 @@
       </p:sp>
       <p:sp>
         <p:nvSpPr>
-          <p:cNvPr id="26" name="Text 23"/>
+          <p:cNvPr id="28" name="Text 25"/>
           <p:cNvSpPr/>
           <p:nvPr/>
         </p:nvSpPr>
@@ -20989,7 +21055,7 @@
       </p:sp>
       <p:sp>
         <p:nvSpPr>
-          <p:cNvPr id="27" name="Shape 24"/>
+          <p:cNvPr id="29" name="Shape 26"/>
           <p:cNvSpPr/>
           <p:nvPr/>
         </p:nvSpPr>
@@ -21014,7 +21080,7 @@
       </p:sp>
       <p:sp>
         <p:nvSpPr>
-          <p:cNvPr id="28" name="Text 25"/>
+          <p:cNvPr id="30" name="Text 27"/>
           <p:cNvSpPr/>
           <p:nvPr/>
         </p:nvSpPr>
@@ -21045,7 +21111,7 @@
                 <a:ea typeface="Pretendard" pitchFamily="34" charset="-122"/>
                 <a:cs typeface="Pretendard" pitchFamily="34" charset="-120"/>
               </a:rPr>
-              <a:t>평균 체류시간</a:t>
+              <a:t>제품 카테고리</a:t>
             </a:r>
             <a:endParaRPr lang="en-US" sz="1200" dirty="0"/>
           </a:p>
@@ -21053,7 +21119,7 @@
       </p:sp>
       <p:sp>
         <p:nvSpPr>
-          <p:cNvPr id="29" name="Text 26"/>
+          <p:cNvPr id="31" name="Text 28"/>
           <p:cNvSpPr/>
           <p:nvPr/>
         </p:nvSpPr>
@@ -21084,7 +21150,7 @@
                 <a:ea typeface="Pretendard" pitchFamily="34" charset="-122"/>
                 <a:cs typeface="Pretendard" pitchFamily="34" charset="-120"/>
               </a:rPr>
-              <a:t>+62%</a:t>
+              <a:t>9개</a:t>
             </a:r>
             <a:endParaRPr lang="en-US" sz="1800" dirty="0"/>
           </a:p>
@@ -21092,7 +21158,7 @@
       </p:sp>
       <p:sp>
         <p:nvSpPr>
-          <p:cNvPr id="30" name="Shape 27"/>
+          <p:cNvPr id="32" name="Shape 29"/>
           <p:cNvSpPr/>
           <p:nvPr/>
         </p:nvSpPr>
@@ -21117,7 +21183,7 @@
       </p:sp>
       <p:sp>
         <p:nvSpPr>
-          <p:cNvPr id="31" name="Text 28"/>
+          <p:cNvPr id="33" name="Text 30"/>
           <p:cNvSpPr/>
           <p:nvPr/>
         </p:nvSpPr>
@@ -21148,7 +21214,7 @@
                 <a:ea typeface="Pretendard" pitchFamily="34" charset="-122"/>
                 <a:cs typeface="Pretendard" pitchFamily="34" charset="-120"/>
               </a:rPr>
-              <a:t>검색 인덱싱</a:t>
+              <a:t>콘텐츠 모듈</a:t>
             </a:r>
             <a:endParaRPr lang="en-US" sz="1200" dirty="0"/>
           </a:p>
@@ -21156,7 +21222,7 @@
       </p:sp>
       <p:sp>
         <p:nvSpPr>
-          <p:cNvPr id="32" name="Text 29"/>
+          <p:cNvPr id="34" name="Text 31"/>
           <p:cNvSpPr/>
           <p:nvPr/>
         </p:nvSpPr>
@@ -21187,7 +21253,7 @@
                 <a:ea typeface="Pretendard" pitchFamily="34" charset="-122"/>
                 <a:cs typeface="Pretendard" pitchFamily="34" charset="-120"/>
               </a:rPr>
-              <a:t>1.7K건</a:t>
+              <a:t>3개</a:t>
             </a:r>
             <a:endParaRPr lang="en-US" sz="1800" dirty="0"/>
           </a:p>
@@ -21195,7 +21261,7 @@
       </p:sp>
       <p:sp>
         <p:nvSpPr>
-          <p:cNvPr id="33" name="Shape 30"/>
+          <p:cNvPr id="35" name="Shape 32"/>
           <p:cNvSpPr/>
           <p:nvPr/>
         </p:nvSpPr>
@@ -21220,7 +21286,7 @@
       </p:sp>
       <p:sp>
         <p:nvSpPr>
-          <p:cNvPr id="34" name="Text 31"/>
+          <p:cNvPr id="36" name="Text 33"/>
           <p:cNvSpPr/>
           <p:nvPr/>
         </p:nvSpPr>
@@ -21251,7 +21317,7 @@
                 <a:ea typeface="Pretendard" pitchFamily="34" charset="-122"/>
                 <a:cs typeface="Pretendard" pitchFamily="34" charset="-120"/>
               </a:rPr>
-              <a:t>모바일 트래픽</a:t>
+              <a:t>운영</a:t>
             </a:r>
             <a:endParaRPr lang="en-US" sz="1200" dirty="0"/>
           </a:p>
@@ -21259,7 +21325,7 @@
       </p:sp>
       <p:sp>
         <p:nvSpPr>
-          <p:cNvPr id="35" name="Text 32"/>
+          <p:cNvPr id="37" name="Text 34"/>
           <p:cNvSpPr/>
           <p:nvPr/>
         </p:nvSpPr>
@@ -21290,7 +21356,7 @@
                 <a:ea typeface="Pretendard" pitchFamily="34" charset="-122"/>
                 <a:cs typeface="Pretendard" pitchFamily="34" charset="-120"/>
               </a:rPr>
-              <a:t>+85%</a:t>
+              <a:t>자체 CMS</a:t>
             </a:r>
             <a:endParaRPr lang="en-US" sz="1800" dirty="0"/>
           </a:p>

</xml_diff>

<commit_message>
Replace slide 2 manifesto with 바이렉스 case (real metrics)
The previous slide 2 body referenced "결혼정보회사 C사 · 3번의 리뉴얼 · 1년 2개월간 360페이지" — that was a generic example carried over from webdot's brochure, not an actual websLAB project.

Replaced with the real 바이렉스 SEO 리뉴얼 case: concrete numbers (1,700 products, 1,712 indexed pages, +214% organic traffic) and a honest description of what we actually did (rebuilt the category structure + admin UI for marketing team self-service).

Reads more like a real case study, less like marketing copy.

Co-Authored-By: Claude Opus 4.7 <noreply@anthropic.com>
</commit_message>
<xml_diff>
--- a/public/files/websLAB-brochure.pptx
+++ b/public/files/websLAB-brochure.pptx
@@ -12297,7 +12297,7 @@
                 <a:ea typeface="Pretendard" pitchFamily="34" charset="-122"/>
                 <a:cs typeface="Pretendard" pitchFamily="34" charset="-120"/>
               </a:rPr>
-              <a:t>결혼정보회사 C사 </a:t>
+              <a:t>바이렉스 </a:t>
             </a:r>
             <a:pPr indent="0" marL="0">
               <a:spcAft>
@@ -12314,7 +12314,7 @@
                 <a:ea typeface="Pretendard" pitchFamily="34" charset="-122"/>
                 <a:cs typeface="Pretendard" pitchFamily="34" charset="-120"/>
               </a:rPr>
-              <a:t>·  3번의 리뉴얼  ·  1년 2개월간 360페이지의 UI/UX 디자인 작업.
+              <a:t>·  6개월  ·  1,700개 상품 카탈로그 SEO 리뉴얼.  검색 인덱싱 1,712건, 자연 유입 +214%.
 </a:t>
             </a:r>
             <a:pPr indent="0" marL="0">
@@ -12332,7 +12332,7 @@
                 <a:ea typeface="Pretendard" pitchFamily="34" charset="-122"/>
                 <a:cs typeface="Pretendard" pitchFamily="34" charset="-120"/>
               </a:rPr>
-              <a:t>websLAB 개발팀은 어떤 상황에서도 맡은 프로젝트를 끝까지 책임지고 마무리합니다. </a:t>
+              <a:t>5년간 운영해온 산업용 부품 사이트의 카테고리 구조부터 다시 짰습니다. 마케팅 팀이 신상품을 직접 등록할 수 있도록 </a:t>
             </a:r>
             <a:pPr indent="0" marL="0">
               <a:spcAft>
@@ -12349,7 +12349,7 @@
                 <a:ea typeface="Pretendard" pitchFamily="34" charset="-122"/>
                 <a:cs typeface="Pretendard" pitchFamily="34" charset="-120"/>
               </a:rPr>
-              <a:t>20인 이하 기업에서, </a:t>
+              <a:t>관리자 페이지까지 함께 만들었고, </a:t>
             </a:r>
             <a:pPr indent="0" marL="0">
               <a:spcAft>
@@ -12366,7 +12366,7 @@
                 <a:ea typeface="Pretendard" pitchFamily="34" charset="-122"/>
                 <a:cs typeface="Pretendard" pitchFamily="34" charset="-120"/>
               </a:rPr>
-              <a:t>사내 개발팀이 없어도 걱정 없이.</a:t>
+              <a:t>검색 노출과 운영성을 동시에 챙겼습니다.</a:t>
             </a:r>
             <a:endParaRPr lang="en-US" sz="1400" dirty="0"/>
           </a:p>

</xml_diff>

<commit_message>
Tone down slide 2 manifesto example to realistic scale
Reverted slide 2 to the original "결혼정보회사 C사" anonymized format but with a much smaller, more realistic scope: 약 2개월간 30여 페이지 UI/UX 디자인 작업 (down from 1년 2개월 / 360페이지).

A small Korean web agency with a 6-person team shouldn't be bragging year-long enterprise-scale deliveries — the original number sounded carried-over from a much bigger studio's brochure (which it was: webdot's). Brought the supporting copy back to the original 책임 + 사내 개발팀 없어도 걱정 없이 framing.

Co-Authored-By: Claude Opus 4.7 <noreply@anthropic.com>
</commit_message>
<xml_diff>
--- a/public/files/websLAB-brochure.pptx
+++ b/public/files/websLAB-brochure.pptx
@@ -12297,7 +12297,7 @@
                 <a:ea typeface="Pretendard" pitchFamily="34" charset="-122"/>
                 <a:cs typeface="Pretendard" pitchFamily="34" charset="-120"/>
               </a:rPr>
-              <a:t>바이렉스 </a:t>
+              <a:t>결혼정보회사 C사 </a:t>
             </a:r>
             <a:pPr indent="0" marL="0">
               <a:spcAft>
@@ -12314,7 +12314,7 @@
                 <a:ea typeface="Pretendard" pitchFamily="34" charset="-122"/>
                 <a:cs typeface="Pretendard" pitchFamily="34" charset="-120"/>
               </a:rPr>
-              <a:t>·  6개월  ·  1,700개 상품 카탈로그 SEO 리뉴얼.  검색 인덱싱 1,712건, 자연 유입 +214%.
+              <a:t>·  약 2개월간 30여 페이지의 UI/UX 디자인 작업.
 </a:t>
             </a:r>
             <a:pPr indent="0" marL="0">
@@ -12332,7 +12332,7 @@
                 <a:ea typeface="Pretendard" pitchFamily="34" charset="-122"/>
                 <a:cs typeface="Pretendard" pitchFamily="34" charset="-120"/>
               </a:rPr>
-              <a:t>5년간 운영해온 산업용 부품 사이트의 카테고리 구조부터 다시 짰습니다. 마케팅 팀이 신상품을 직접 등록할 수 있도록 </a:t>
+              <a:t>websLAB 개발팀은 어떤 상황에서도 맡은 프로젝트를 끝까지 책임지고 마무리합니다. </a:t>
             </a:r>
             <a:pPr indent="0" marL="0">
               <a:spcAft>
@@ -12349,7 +12349,7 @@
                 <a:ea typeface="Pretendard" pitchFamily="34" charset="-122"/>
                 <a:cs typeface="Pretendard" pitchFamily="34" charset="-120"/>
               </a:rPr>
-              <a:t>관리자 페이지까지 함께 만들었고, </a:t>
+              <a:t>20인 이하 기업에서, </a:t>
             </a:r>
             <a:pPr indent="0" marL="0">
               <a:spcAft>
@@ -12366,7 +12366,7 @@
                 <a:ea typeface="Pretendard" pitchFamily="34" charset="-122"/>
                 <a:cs typeface="Pretendard" pitchFamily="34" charset="-120"/>
               </a:rPr>
-              <a:t>검색 노출과 운영성을 동시에 챙겼습니다.</a:t>
+              <a:t>사내 개발팀이 없어도 걱정 없이.</a:t>
             </a:r>
             <a:endParaRPr lang="en-US" sz="1400" dirty="0"/>
           </a:p>

</xml_diff>